<commit_message>
Geschichte 11: konkretere Arbeitsaufträge auf den Folien, Problemzeilen ohne Kürzel
Co-Authored-By: Claude Opus 5.5 <noreply@anthropic.com>
Claude-Session: https://claude.ai/code/session_013iN4Tiarea1J9YUJHZ9iqC
</commit_message>
<xml_diff>
--- a/Geschichte_11/Doppelstunde_Solon/Folien_Doppelstunde_Drakon_Solon.pptx
+++ b/Geschichte_11/Doppelstunde_Solon/Folien_Doppelstunde_Drakon_Solon.pptx
@@ -2117,7 +2117,7 @@
           <a:p>
             <a:r>
               <a:rPr lang="en-US" dirty="0"/>
-              <a:t>30–38 Min. Erwartung: P1 ✘ (Schuldknechtschaft bleibt), P2 ✘, P3 ~ (geschriebenes, verbindliches Recht, 51 Richter, Blutrache aufgehoben; Vollzug bleibt bei der Sippe), P4 ✘, P5 ✘. Das Beispiel P3 bewusst stehen lassen – es zeigt, wie ein Beleg aussieht.</a:t>
+              <a:t>30–38 Min. Erwartung: Schuldknechtschaft ✘ (Schuldknechtschaft bleibt), Landbesitz ✘, Recht ~ (geschriebenes, verbindliches Recht, 51 Richter, Blutrache aufgehoben; Vollzug bleibt bei der Sippe), Politische Macht ✘, Bürgerkrieg ✘. Das Beispiel „Recht nur beim Adel“ bewusst stehen lassen – es zeigt, wie ein Beleg aussieht.</a:t>
             </a:r>
             <a:endParaRPr lang="en-US" dirty="0"/>
           </a:p>
@@ -2384,11 +2384,11 @@
             <a:r>
               <a:rPr lang="en-US" dirty="0"/>
               <a:t>57–63 Min. Erst NACH der Besprechung zeigen. Begründungen:
-P1: Drakon ✘ / Solon ✔ Schulden getilgt, Verbot der Schuldknechtschaft, Rückkauf.
-P2: beide ✘ – Solon lehnt die Zwangsenteignung ab.
-P3: Drakon ~ geschriebenes Recht, Ende der Blutrache, aber strenge Strafen / Solon ✔ Klagerecht jedes Bürgers.
-P4: Solon ~ Rechte nach Besitz statt Herkunft, Volksversammlung gestärkt – aber Theten nicht wählbar, Archonten nur 1. Klasse.
-P5: Solon ~ zunächst Beruhigung, bald neue bürgerkriegsähnliche Kämpfe (LB S. 22).
+Schuldknechtschaft: Drakon ✘ / Solon ✔ Schulden getilgt, Verbot der Schuldknechtschaft, Rückkauf.
+Landbesitz: beide ✘ – Solon lehnt die Zwangsenteignung ab.
+Recht: Drakon ~ geschriebenes Recht, Ende der Blutrache, aber strenge Strafen / Solon ✔ Klagerecht jedes Bürgers.
+Politische Macht: Solon ~ Rechte nach Besitz statt Herkunft, Volksversammlung gestärkt – aber Theten nicht wählbar, Archonten nur 1. Klasse.
+Bürgerkrieg: Solon ~ zunächst Beruhigung, bald neue bürgerkriegsähnliche Kämpfe (LB S. 22).
 Abweichende, gut begründete Einschätzungen sind zulässig.</a:t>
             </a:r>
             <a:endParaRPr lang="en-US" dirty="0"/>
@@ -8874,24 +8874,24 @@
         </p:nvSpPr>
         <p:spPr>
           <a:xfrm>
-            <a:off x="457200" y="1115568"/>
-            <a:ext cx="8229600" cy="274320"/>
-          </a:xfrm>
-          <a:prstGeom prst="rect">
-            <a:avLst/>
-          </a:prstGeom>
-          <a:noFill/>
-          <a:ln/>
-        </p:spPr>
-        <p:txBody>
-          <a:bodyPr wrap="square" lIns="0" tIns="0" rIns="0" bIns="0" rtlCol="0" anchor="t"/>
-          <a:lstStyle/>
-          <a:p>
-            <a:pPr indent="0" marL="0">
-              <a:buNone/>
-            </a:pPr>
-            <a:r>
-              <a:rPr lang="en-US" sz="1300" i="1" dirty="0">
+            <a:off x="457200" y="1097280"/>
+            <a:ext cx="8229600" cy="420624"/>
+          </a:xfrm>
+          <a:prstGeom prst="rect">
+            <a:avLst/>
+          </a:prstGeom>
+          <a:noFill/>
+          <a:ln/>
+        </p:spPr>
+        <p:txBody>
+          <a:bodyPr wrap="square" lIns="0" tIns="0" rIns="0" bIns="0" rtlCol="0" anchor="ctr"/>
+          <a:lstStyle/>
+          <a:p>
+            <a:pPr indent="0" marL="0">
+              <a:buNone/>
+            </a:pPr>
+            <a:r>
+              <a:rPr lang="en-US" sz="1200" b="1" dirty="0">
                 <a:solidFill>
                   <a:srgbClr val="5A5044"/>
                 </a:solidFill>
@@ -8899,9 +8899,9 @@
                 <a:ea typeface="Calibri" pitchFamily="34" charset="-122"/>
                 <a:cs typeface="Calibri" pitchFamily="34" charset="-120"/>
               </a:rPr>
-              <a:t>Ergänzt die Lücken 1–14 mit dem Wortspeicher. Fett gedruckt: neue Begriffe.</a:t>
-            </a:r>
-            <a:endParaRPr lang="en-US" sz="1300" dirty="0"/>
+              <a:t>1. Lies den Text auf deinem Blatt.   2. Setze die Wörter aus dem Wortspeicher ein (jedes passt genau einmal).   3. Vergleiche mit deinem Nachbarn.</a:t>
+            </a:r>
+            <a:endParaRPr lang="en-US" sz="1200" dirty="0"/>
           </a:p>
         </p:txBody>
       </p:sp>
@@ -8913,12 +8913,12 @@
         </p:nvSpPr>
         <p:spPr>
           <a:xfrm>
-            <a:off x="457200" y="1444752"/>
-            <a:ext cx="8229600" cy="2286000"/>
+            <a:off x="457200" y="1572768"/>
+            <a:ext cx="8229600" cy="2139696"/>
           </a:xfrm>
           <a:prstGeom prst="roundRect">
             <a:avLst>
-              <a:gd name="adj" fmla="val 3200"/>
+              <a:gd name="adj" fmla="val 3419"/>
             </a:avLst>
           </a:prstGeom>
           <a:solidFill>
@@ -8940,8 +8940,8 @@
         </p:nvSpPr>
         <p:spPr>
           <a:xfrm>
-            <a:off x="621792" y="1490472"/>
-            <a:ext cx="7900416" cy="2194560"/>
+            <a:off x="621792" y="1600200"/>
+            <a:ext cx="7900416" cy="2084832"/>
           </a:xfrm>
           <a:prstGeom prst="rect">
             <a:avLst/>
@@ -8957,7 +8957,7 @@
               <a:buNone/>
             </a:pPr>
             <a:r>
-              <a:rPr lang="en-US" sz="1350" dirty="0">
+              <a:rPr lang="en-US" sz="1300" dirty="0">
                 <a:solidFill>
                   <a:srgbClr val="2B2318"/>
                 </a:solidFill>
@@ -8971,7 +8971,7 @@
               <a:buNone/>
             </a:pPr>
             <a:r>
-              <a:rPr lang="en-US" sz="1350" b="1" dirty="0">
+              <a:rPr lang="en-US" sz="1300" b="1" dirty="0">
                 <a:solidFill>
                   <a:srgbClr val="AD4426"/>
                 </a:solidFill>
@@ -8985,7 +8985,7 @@
               <a:buNone/>
             </a:pPr>
             <a:r>
-              <a:rPr lang="en-US" sz="1350" dirty="0">
+              <a:rPr lang="en-US" sz="1300" dirty="0">
                 <a:solidFill>
                   <a:srgbClr val="2B2318"/>
                 </a:solidFill>
@@ -8999,7 +8999,7 @@
               <a:buNone/>
             </a:pPr>
             <a:r>
-              <a:rPr lang="en-US" sz="1350" b="1" dirty="0">
+              <a:rPr lang="en-US" sz="1300" b="1" dirty="0">
                 <a:solidFill>
                   <a:srgbClr val="AD4426"/>
                 </a:solidFill>
@@ -9013,7 +9013,7 @@
               <a:buNone/>
             </a:pPr>
             <a:r>
-              <a:rPr lang="en-US" sz="1350" dirty="0">
+              <a:rPr lang="en-US" sz="1300" dirty="0">
                 <a:solidFill>
                   <a:srgbClr val="2B2318"/>
                 </a:solidFill>
@@ -9027,7 +9027,7 @@
               <a:buNone/>
             </a:pPr>
             <a:r>
-              <a:rPr lang="en-US" sz="1350" b="1" dirty="0">
+              <a:rPr lang="en-US" sz="1300" b="1" dirty="0">
                 <a:solidFill>
                   <a:srgbClr val="AD4426"/>
                 </a:solidFill>
@@ -9041,7 +9041,7 @@
               <a:buNone/>
             </a:pPr>
             <a:r>
-              <a:rPr lang="en-US" sz="1350" dirty="0">
+              <a:rPr lang="en-US" sz="1300" dirty="0">
                 <a:solidFill>
                   <a:srgbClr val="2B2318"/>
                 </a:solidFill>
@@ -9055,7 +9055,7 @@
               <a:buNone/>
             </a:pPr>
             <a:r>
-              <a:rPr lang="en-US" sz="1350" b="1" dirty="0">
+              <a:rPr lang="en-US" sz="1300" b="1" dirty="0">
                 <a:solidFill>
                   <a:srgbClr val="AD4426"/>
                 </a:solidFill>
@@ -9069,7 +9069,7 @@
               <a:buNone/>
             </a:pPr>
             <a:r>
-              <a:rPr lang="en-US" sz="1350" dirty="0">
+              <a:rPr lang="en-US" sz="1300" dirty="0">
                 <a:solidFill>
                   <a:srgbClr val="2B2318"/>
                 </a:solidFill>
@@ -9082,7 +9082,7 @@
             <a:pPr indent="0" marL="0">
               <a:buNone/>
             </a:pPr>
-            <a:endParaRPr lang="en-US" sz="1350" dirty="0"/>
+            <a:endParaRPr lang="en-US" sz="1300" dirty="0"/>
           </a:p>
           <a:p>
             <a:pPr indent="0" marL="0">
@@ -9099,14 +9099,14 @@
               </a:rPr>
               <a:t> </a:t>
             </a:r>
-            <a:endParaRPr lang="en-US" sz="1350" dirty="0"/>
-          </a:p>
-          <a:p>
-            <a:pPr indent="0" marL="0">
-              <a:buNone/>
-            </a:pPr>
-            <a:r>
-              <a:rPr lang="en-US" sz="1350" dirty="0">
+            <a:endParaRPr lang="en-US" sz="1300" dirty="0"/>
+          </a:p>
+          <a:p>
+            <a:pPr indent="0" marL="0">
+              <a:buNone/>
+            </a:pPr>
+            <a:r>
+              <a:rPr lang="en-US" sz="1300" dirty="0">
                 <a:solidFill>
                   <a:srgbClr val="2B2318"/>
                 </a:solidFill>
@@ -9120,7 +9120,7 @@
               <a:buNone/>
             </a:pPr>
             <a:r>
-              <a:rPr lang="en-US" sz="1350" b="1" dirty="0">
+              <a:rPr lang="en-US" sz="1300" b="1" dirty="0">
                 <a:solidFill>
                   <a:srgbClr val="AD4426"/>
                 </a:solidFill>
@@ -9134,7 +9134,7 @@
               <a:buNone/>
             </a:pPr>
             <a:r>
-              <a:rPr lang="en-US" sz="1350" dirty="0">
+              <a:rPr lang="en-US" sz="1300" dirty="0">
                 <a:solidFill>
                   <a:srgbClr val="2B2318"/>
                 </a:solidFill>
@@ -9148,7 +9148,7 @@
               <a:buNone/>
             </a:pPr>
             <a:r>
-              <a:rPr lang="en-US" sz="1350" b="1" dirty="0">
+              <a:rPr lang="en-US" sz="1300" b="1" dirty="0">
                 <a:solidFill>
                   <a:srgbClr val="AD4426"/>
                 </a:solidFill>
@@ -9162,7 +9162,7 @@
               <a:buNone/>
             </a:pPr>
             <a:r>
-              <a:rPr lang="en-US" sz="1350" dirty="0">
+              <a:rPr lang="en-US" sz="1300" dirty="0">
                 <a:solidFill>
                   <a:srgbClr val="2B2318"/>
                 </a:solidFill>
@@ -9176,7 +9176,7 @@
               <a:buNone/>
             </a:pPr>
             <a:r>
-              <a:rPr lang="en-US" sz="1350" b="1" dirty="0">
+              <a:rPr lang="en-US" sz="1300" b="1" dirty="0">
                 <a:solidFill>
                   <a:srgbClr val="AD4426"/>
                 </a:solidFill>
@@ -9190,7 +9190,7 @@
               <a:buNone/>
             </a:pPr>
             <a:r>
-              <a:rPr lang="en-US" sz="1350" dirty="0">
+              <a:rPr lang="en-US" sz="1300" dirty="0">
                 <a:solidFill>
                   <a:srgbClr val="2B2318"/>
                 </a:solidFill>
@@ -9204,7 +9204,7 @@
               <a:buNone/>
             </a:pPr>
             <a:r>
-              <a:rPr lang="en-US" sz="1350" b="1" dirty="0">
+              <a:rPr lang="en-US" sz="1300" b="1" dirty="0">
                 <a:solidFill>
                   <a:srgbClr val="AD4426"/>
                 </a:solidFill>
@@ -9218,7 +9218,7 @@
               <a:buNone/>
             </a:pPr>
             <a:r>
-              <a:rPr lang="en-US" sz="1350" dirty="0">
+              <a:rPr lang="en-US" sz="1300" dirty="0">
                 <a:solidFill>
                   <a:srgbClr val="2B2318"/>
                 </a:solidFill>
@@ -9228,7 +9228,7 @@
               </a:rPr>
               <a:t> (griechisch: „Zusammensiedlung“).</a:t>
             </a:r>
-            <a:endParaRPr lang="en-US" sz="1350" dirty="0"/>
+            <a:endParaRPr lang="en-US" sz="1300" dirty="0"/>
           </a:p>
         </p:txBody>
       </p:sp>
@@ -10853,24 +10853,24 @@
         </p:nvSpPr>
         <p:spPr>
           <a:xfrm>
-            <a:off x="457200" y="1115568"/>
-            <a:ext cx="8229600" cy="274320"/>
-          </a:xfrm>
-          <a:prstGeom prst="rect">
-            <a:avLst/>
-          </a:prstGeom>
-          <a:noFill/>
-          <a:ln/>
-        </p:spPr>
-        <p:txBody>
-          <a:bodyPr wrap="square" lIns="0" tIns="0" rIns="0" bIns="0" rtlCol="0" anchor="t"/>
-          <a:lstStyle/>
-          <a:p>
-            <a:pPr indent="0" marL="0">
-              <a:buNone/>
-            </a:pPr>
-            <a:r>
-              <a:rPr lang="en-US" sz="1300" i="1" dirty="0">
+            <a:off x="457200" y="1097280"/>
+            <a:ext cx="8229600" cy="420624"/>
+          </a:xfrm>
+          <a:prstGeom prst="rect">
+            <a:avLst/>
+          </a:prstGeom>
+          <a:noFill/>
+          <a:ln/>
+        </p:spPr>
+        <p:txBody>
+          <a:bodyPr wrap="square" lIns="0" tIns="0" rIns="0" bIns="0" rtlCol="0" anchor="ctr"/>
+          <a:lstStyle/>
+          <a:p>
+            <a:pPr indent="0" marL="0">
+              <a:buNone/>
+            </a:pPr>
+            <a:r>
+              <a:rPr lang="en-US" sz="1200" b="1" dirty="0">
                 <a:solidFill>
                   <a:srgbClr val="5A5044"/>
                 </a:solidFill>
@@ -10878,9 +10878,9 @@
                 <a:ea typeface="Calibri" pitchFamily="34" charset="-122"/>
                 <a:cs typeface="Calibri" pitchFamily="34" charset="-120"/>
               </a:rPr>
-              <a:t>Ergänzt die Lücken 7–14.</a:t>
-            </a:r>
-            <a:endParaRPr lang="en-US" sz="1300" dirty="0"/>
+              <a:t>Ergänze die Lücken 7–14. Schreibe danach unter den Text in einem Satz: Was passiert, wenn die Bauern ihre Schulden nicht zurückzahlen können?</a:t>
+            </a:r>
+            <a:endParaRPr lang="en-US" sz="1200" dirty="0"/>
           </a:p>
         </p:txBody>
       </p:sp>
@@ -10892,12 +10892,12 @@
         </p:nvSpPr>
         <p:spPr>
           <a:xfrm>
-            <a:off x="457200" y="1444752"/>
-            <a:ext cx="8229600" cy="2286000"/>
+            <a:off x="457200" y="1572768"/>
+            <a:ext cx="8229600" cy="2139696"/>
           </a:xfrm>
           <a:prstGeom prst="roundRect">
             <a:avLst>
-              <a:gd name="adj" fmla="val 3200"/>
+              <a:gd name="adj" fmla="val 3419"/>
             </a:avLst>
           </a:prstGeom>
           <a:solidFill>
@@ -10919,8 +10919,8 @@
         </p:nvSpPr>
         <p:spPr>
           <a:xfrm>
-            <a:off x="621792" y="1490472"/>
-            <a:ext cx="7900416" cy="2194560"/>
+            <a:off x="621792" y="1600200"/>
+            <a:ext cx="7900416" cy="2084832"/>
           </a:xfrm>
           <a:prstGeom prst="rect">
             <a:avLst/>
@@ -10936,7 +10936,7 @@
               <a:buNone/>
             </a:pPr>
             <a:r>
-              <a:rPr lang="en-US" sz="1250" dirty="0">
+              <a:rPr lang="en-US" sz="1200" dirty="0">
                 <a:solidFill>
                   <a:srgbClr val="2B2318"/>
                 </a:solidFill>
@@ -10950,7 +10950,7 @@
               <a:buNone/>
             </a:pPr>
             <a:r>
-              <a:rPr lang="en-US" sz="1250" b="1" dirty="0">
+              <a:rPr lang="en-US" sz="1200" b="1" dirty="0">
                 <a:solidFill>
                   <a:srgbClr val="AD4426"/>
                 </a:solidFill>
@@ -10964,7 +10964,7 @@
               <a:buNone/>
             </a:pPr>
             <a:r>
-              <a:rPr lang="en-US" sz="1250" dirty="0">
+              <a:rPr lang="en-US" sz="1200" dirty="0">
                 <a:solidFill>
                   <a:srgbClr val="2B2318"/>
                 </a:solidFill>
@@ -10978,7 +10978,7 @@
               <a:buNone/>
             </a:pPr>
             <a:r>
-              <a:rPr lang="en-US" sz="1250" b="1" dirty="0">
+              <a:rPr lang="en-US" sz="1200" b="1" dirty="0">
                 <a:solidFill>
                   <a:srgbClr val="AD4426"/>
                 </a:solidFill>
@@ -10992,7 +10992,7 @@
               <a:buNone/>
             </a:pPr>
             <a:r>
-              <a:rPr lang="en-US" sz="1250" dirty="0">
+              <a:rPr lang="en-US" sz="1200" dirty="0">
                 <a:solidFill>
                   <a:srgbClr val="2B2318"/>
                 </a:solidFill>
@@ -11005,7 +11005,7 @@
             <a:pPr indent="0" marL="0">
               <a:buNone/>
             </a:pPr>
-            <a:endParaRPr lang="en-US" sz="1250" dirty="0"/>
+            <a:endParaRPr lang="en-US" sz="1200" dirty="0"/>
           </a:p>
           <a:p>
             <a:pPr indent="0" marL="0">
@@ -11022,14 +11022,14 @@
               </a:rPr>
               <a:t> </a:t>
             </a:r>
-            <a:endParaRPr lang="en-US" sz="1250" dirty="0"/>
-          </a:p>
-          <a:p>
-            <a:pPr indent="0" marL="0">
-              <a:buNone/>
-            </a:pPr>
-            <a:r>
-              <a:rPr lang="en-US" sz="1250" dirty="0">
+            <a:endParaRPr lang="en-US" sz="1200" dirty="0"/>
+          </a:p>
+          <a:p>
+            <a:pPr indent="0" marL="0">
+              <a:buNone/>
+            </a:pPr>
+            <a:r>
+              <a:rPr lang="en-US" sz="1200" dirty="0">
                 <a:solidFill>
                   <a:srgbClr val="2B2318"/>
                 </a:solidFill>
@@ -11043,7 +11043,7 @@
               <a:buNone/>
             </a:pPr>
             <a:r>
-              <a:rPr lang="en-US" sz="1250" b="1" dirty="0">
+              <a:rPr lang="en-US" sz="1200" b="1" dirty="0">
                 <a:solidFill>
                   <a:srgbClr val="AD4426"/>
                 </a:solidFill>
@@ -11057,7 +11057,7 @@
               <a:buNone/>
             </a:pPr>
             <a:r>
-              <a:rPr lang="en-US" sz="1250" dirty="0">
+              <a:rPr lang="en-US" sz="1200" dirty="0">
                 <a:solidFill>
                   <a:srgbClr val="2B2318"/>
                 </a:solidFill>
@@ -11071,7 +11071,7 @@
               <a:buNone/>
             </a:pPr>
             <a:r>
-              <a:rPr lang="en-US" sz="1250" b="1" dirty="0">
+              <a:rPr lang="en-US" sz="1200" b="1" dirty="0">
                 <a:solidFill>
                   <a:srgbClr val="AD4426"/>
                 </a:solidFill>
@@ -11085,7 +11085,7 @@
               <a:buNone/>
             </a:pPr>
             <a:r>
-              <a:rPr lang="en-US" sz="1250" dirty="0">
+              <a:rPr lang="en-US" sz="1200" dirty="0">
                 <a:solidFill>
                   <a:srgbClr val="2B2318"/>
                 </a:solidFill>
@@ -11099,7 +11099,7 @@
               <a:buNone/>
             </a:pPr>
             <a:r>
-              <a:rPr lang="en-US" sz="1250" b="1" dirty="0">
+              <a:rPr lang="en-US" sz="1200" b="1" dirty="0">
                 <a:solidFill>
                   <a:srgbClr val="AD4426"/>
                 </a:solidFill>
@@ -11113,7 +11113,7 @@
               <a:buNone/>
             </a:pPr>
             <a:r>
-              <a:rPr lang="en-US" sz="1250" dirty="0">
+              <a:rPr lang="en-US" sz="1200" dirty="0">
                 <a:solidFill>
                   <a:srgbClr val="2B2318"/>
                 </a:solidFill>
@@ -11127,7 +11127,7 @@
               <a:buNone/>
             </a:pPr>
             <a:r>
-              <a:rPr lang="en-US" sz="1250" b="1" dirty="0">
+              <a:rPr lang="en-US" sz="1200" b="1" dirty="0">
                 <a:solidFill>
                   <a:srgbClr val="AD4426"/>
                 </a:solidFill>
@@ -11141,7 +11141,7 @@
               <a:buNone/>
             </a:pPr>
             <a:r>
-              <a:rPr lang="en-US" sz="1250" dirty="0">
+              <a:rPr lang="en-US" sz="1200" dirty="0">
                 <a:solidFill>
                   <a:srgbClr val="2B2318"/>
                 </a:solidFill>
@@ -11155,7 +11155,7 @@
               <a:buNone/>
             </a:pPr>
             <a:r>
-              <a:rPr lang="en-US" sz="1250" b="1" dirty="0">
+              <a:rPr lang="en-US" sz="1200" b="1" dirty="0">
                 <a:solidFill>
                   <a:srgbClr val="AD4426"/>
                 </a:solidFill>
@@ -11169,7 +11169,7 @@
               <a:buNone/>
             </a:pPr>
             <a:r>
-              <a:rPr lang="en-US" sz="1250" dirty="0">
+              <a:rPr lang="en-US" sz="1200" dirty="0">
                 <a:solidFill>
                   <a:srgbClr val="2B2318"/>
                 </a:solidFill>
@@ -11182,7 +11182,7 @@
             <a:pPr indent="0" marL="0">
               <a:buNone/>
             </a:pPr>
-            <a:endParaRPr lang="en-US" sz="1250" dirty="0"/>
+            <a:endParaRPr lang="en-US" sz="1200" dirty="0"/>
           </a:p>
           <a:p>
             <a:pPr indent="0" marL="0">
@@ -11199,14 +11199,14 @@
               </a:rPr>
               <a:t> </a:t>
             </a:r>
-            <a:endParaRPr lang="en-US" sz="1250" dirty="0"/>
-          </a:p>
-          <a:p>
-            <a:pPr indent="0" marL="0">
-              <a:buNone/>
-            </a:pPr>
-            <a:r>
-              <a:rPr lang="en-US" sz="1250" dirty="0">
+            <a:endParaRPr lang="en-US" sz="1200" dirty="0"/>
+          </a:p>
+          <a:p>
+            <a:pPr indent="0" marL="0">
+              <a:buNone/>
+            </a:pPr>
+            <a:r>
+              <a:rPr lang="en-US" sz="1200" dirty="0">
                 <a:solidFill>
                   <a:srgbClr val="2B2318"/>
                 </a:solidFill>
@@ -11220,7 +11220,7 @@
               <a:buNone/>
             </a:pPr>
             <a:r>
-              <a:rPr lang="en-US" sz="1250" b="1" dirty="0">
+              <a:rPr lang="en-US" sz="1200" b="1" dirty="0">
                 <a:solidFill>
                   <a:srgbClr val="AD4426"/>
                 </a:solidFill>
@@ -11234,7 +11234,7 @@
               <a:buNone/>
             </a:pPr>
             <a:r>
-              <a:rPr lang="en-US" sz="1250" dirty="0">
+              <a:rPr lang="en-US" sz="1200" dirty="0">
                 <a:solidFill>
                   <a:srgbClr val="2B2318"/>
                 </a:solidFill>
@@ -11244,7 +11244,7 @@
               </a:rPr>
               <a:t>.</a:t>
             </a:r>
-            <a:endParaRPr lang="en-US" sz="1250" dirty="0"/>
+            <a:endParaRPr lang="en-US" sz="1200" dirty="0"/>
           </a:p>
         </p:txBody>
       </p:sp>
@@ -13276,12 +13276,12 @@
         </p:nvSpPr>
         <p:spPr>
           <a:xfrm>
-            <a:off x="457200" y="2560320"/>
-            <a:ext cx="4754880" cy="1691640"/>
+            <a:off x="457200" y="2487168"/>
+            <a:ext cx="4754880" cy="1920240"/>
           </a:xfrm>
           <a:prstGeom prst="roundRect">
             <a:avLst>
-              <a:gd name="adj" fmla="val 4324"/>
+              <a:gd name="adj" fmla="val 3810"/>
             </a:avLst>
           </a:prstGeom>
           <a:solidFill>
@@ -13303,8 +13303,90 @@
         </p:nvSpPr>
         <p:spPr>
           <a:xfrm>
-            <a:off x="685800" y="2697480"/>
-            <a:ext cx="4389120" cy="548640"/>
+            <a:off x="658368" y="2578608"/>
+            <a:ext cx="4434840" cy="1188720"/>
+          </a:xfrm>
+          <a:prstGeom prst="rect">
+            <a:avLst/>
+          </a:prstGeom>
+          <a:noFill/>
+          <a:ln/>
+        </p:spPr>
+        <p:txBody>
+          <a:bodyPr wrap="square" lIns="0" tIns="0" rIns="0" bIns="0" rtlCol="0" anchor="ctr"/>
+          <a:lstStyle/>
+          <a:p>
+            <a:pPr indent="0" marL="0">
+              <a:spcAft>
+                <a:spcPts val="300"/>
+              </a:spcAft>
+              <a:buNone/>
+            </a:pPr>
+            <a:r>
+              <a:rPr lang="en-US" sz="1200" dirty="0">
+                <a:solidFill>
+                  <a:srgbClr val="2B2318"/>
+                </a:solidFill>
+                <a:latin typeface="Calibri" pitchFamily="34" charset="0"/>
+                <a:ea typeface="Calibri" pitchFamily="34" charset="-122"/>
+                <a:cs typeface="Calibri" pitchFamily="34" charset="-120"/>
+              </a:rPr>
+              <a:t>1. Entscheide dich für einen Faktor, z. B. Gebirge, Landmangel oder Adel.</a:t>
+            </a:r>
+            <a:endParaRPr lang="en-US" sz="1200" dirty="0"/>
+          </a:p>
+          <a:p>
+            <a:pPr indent="0" marL="0">
+              <a:spcAft>
+                <a:spcPts val="300"/>
+              </a:spcAft>
+              <a:buNone/>
+            </a:pPr>
+            <a:r>
+              <a:rPr lang="en-US" sz="1200" dirty="0">
+                <a:solidFill>
+                  <a:srgbClr val="2B2318"/>
+                </a:solidFill>
+                <a:latin typeface="Calibri" pitchFamily="34" charset="0"/>
+                <a:ea typeface="Calibri" pitchFamily="34" charset="-122"/>
+                <a:cs typeface="Calibri" pitchFamily="34" charset="-120"/>
+              </a:rPr>
+              <a:t>2. Begründe in 2–3 Sätzen mit Informationen aus dem Lückentext.</a:t>
+            </a:r>
+            <a:endParaRPr lang="en-US" sz="1200" dirty="0"/>
+          </a:p>
+          <a:p>
+            <a:pPr indent="0" marL="0">
+              <a:spcAft>
+                <a:spcPts val="300"/>
+              </a:spcAft>
+              <a:buNone/>
+            </a:pPr>
+            <a:r>
+              <a:rPr lang="en-US" sz="1200" dirty="0">
+                <a:solidFill>
+                  <a:srgbClr val="2B2318"/>
+                </a:solidFill>
+                <a:latin typeface="Calibri" pitchFamily="34" charset="0"/>
+                <a:ea typeface="Calibri" pitchFamily="34" charset="-122"/>
+                <a:cs typeface="Calibri" pitchFamily="34" charset="-120"/>
+              </a:rPr>
+              <a:t>3. Tausche mit deinem Nachbarn und prüft mit der Checkliste.</a:t>
+            </a:r>
+            <a:endParaRPr lang="en-US" sz="1200" dirty="0"/>
+          </a:p>
+        </p:txBody>
+      </p:sp>
+      <p:sp>
+        <p:nvSpPr>
+          <p:cNvPr id="9" name="Text 7"/>
+          <p:cNvSpPr txBox="1"/>
+          <p:nvPr/>
+        </p:nvSpPr>
+        <p:spPr>
+          <a:xfrm>
+            <a:off x="658368" y="3840480"/>
+            <a:ext cx="4434840" cy="502920"/>
           </a:xfrm>
           <a:prstGeom prst="rect">
             <a:avLst/>
@@ -13320,46 +13402,7 @@
               <a:buNone/>
             </a:pPr>
             <a:r>
-              <a:rPr lang="en-US" sz="1400" b="1" dirty="0">
-                <a:solidFill>
-                  <a:srgbClr val="2B2318"/>
-                </a:solidFill>
-                <a:latin typeface="Calibri" pitchFamily="34" charset="0"/>
-                <a:ea typeface="Calibri" pitchFamily="34" charset="-122"/>
-                <a:cs typeface="Calibri" pitchFamily="34" charset="-120"/>
-              </a:rPr>
-              <a:t>Schreibt 2–3 Sätze. Nutzt den Lückentext.</a:t>
-            </a:r>
-            <a:endParaRPr lang="en-US" sz="1400" dirty="0"/>
-          </a:p>
-        </p:txBody>
-      </p:sp>
-      <p:sp>
-        <p:nvSpPr>
-          <p:cNvPr id="9" name="Text 7"/>
-          <p:cNvSpPr txBox="1"/>
-          <p:nvPr/>
-        </p:nvSpPr>
-        <p:spPr>
-          <a:xfrm>
-            <a:off x="685800" y="3337560"/>
-            <a:ext cx="4389120" cy="822960"/>
-          </a:xfrm>
-          <a:prstGeom prst="rect">
-            <a:avLst/>
-          </a:prstGeom>
-          <a:noFill/>
-          <a:ln/>
-        </p:spPr>
-        <p:txBody>
-          <a:bodyPr wrap="square" lIns="0" tIns="0" rIns="0" bIns="0" rtlCol="0" anchor="t"/>
-          <a:lstStyle/>
-          <a:p>
-            <a:pPr indent="0" marL="0">
-              <a:buNone/>
-            </a:pPr>
-            <a:r>
-              <a:rPr lang="en-US" sz="1400" i="1" dirty="0">
+              <a:rPr lang="en-US" sz="1200" i="1" dirty="0">
                 <a:solidFill>
                   <a:srgbClr val="5A5044"/>
                 </a:solidFill>
@@ -13369,7 +13412,7 @@
               </a:rPr>
               <a:t>„Im Kontext der damaligen Zeit war … am wichtigsten, da … Dies führte zu …“</a:t>
             </a:r>
-            <a:endParaRPr lang="en-US" sz="1400" dirty="0"/>
+            <a:endParaRPr lang="en-US" sz="1200" dirty="0"/>
           </a:p>
         </p:txBody>
       </p:sp>
@@ -13381,12 +13424,12 @@
         </p:nvSpPr>
         <p:spPr>
           <a:xfrm>
-            <a:off x="5440680" y="2560320"/>
-            <a:ext cx="3246120" cy="1691640"/>
+            <a:off x="5440680" y="2487168"/>
+            <a:ext cx="3246120" cy="1920240"/>
           </a:xfrm>
           <a:prstGeom prst="roundRect">
             <a:avLst>
-              <a:gd name="adj" fmla="val 4324"/>
+              <a:gd name="adj" fmla="val 3810"/>
             </a:avLst>
           </a:prstGeom>
           <a:solidFill>
@@ -13876,8 +13919,8 @@
         </p:nvSpPr>
         <p:spPr>
           <a:xfrm>
-            <a:off x="731520" y="1965960"/>
-            <a:ext cx="4389120" cy="1097280"/>
+            <a:off x="731520" y="1920240"/>
+            <a:ext cx="4389120" cy="685800"/>
           </a:xfrm>
           <a:prstGeom prst="rect">
             <a:avLst/>
@@ -13893,7 +13936,7 @@
               <a:buNone/>
             </a:pPr>
             <a:r>
-              <a:rPr lang="en-US" sz="2200" b="1" dirty="0">
+              <a:rPr lang="en-US" sz="2000" b="1" dirty="0">
                 <a:solidFill>
                   <a:srgbClr val="FFFFFF"/>
                 </a:solidFill>
@@ -13901,9 +13944,9 @@
                 <a:ea typeface="Cambria" pitchFamily="34" charset="-122"/>
                 <a:cs typeface="Cambria" pitchFamily="34" charset="-120"/>
               </a:rPr>
-              <a:t>Notiert beim Hören: Welche Probleme hat Athen?</a:t>
-            </a:r>
-            <a:endParaRPr lang="en-US" sz="2200" dirty="0"/>
+              <a:t>Welche Probleme hat Athen um 600 v. Chr.?</a:t>
+            </a:r>
+            <a:endParaRPr lang="en-US" sz="2000" dirty="0"/>
           </a:p>
         </p:txBody>
       </p:sp>
@@ -13915,24 +13958,27 @@
         </p:nvSpPr>
         <p:spPr>
           <a:xfrm>
-            <a:off x="731520" y="3154680"/>
-            <a:ext cx="4389120" cy="365760"/>
-          </a:xfrm>
-          <a:prstGeom prst="rect">
-            <a:avLst/>
-          </a:prstGeom>
-          <a:noFill/>
-          <a:ln/>
-        </p:spPr>
-        <p:txBody>
-          <a:bodyPr wrap="square" lIns="0" tIns="0" rIns="0" bIns="0" rtlCol="0" anchor="t"/>
-          <a:lstStyle/>
-          <a:p>
-            <a:pPr indent="0" marL="0">
-              <a:buNone/>
-            </a:pPr>
-            <a:r>
-              <a:rPr lang="en-US" sz="1400" dirty="0">
+            <a:off x="731520" y="2697480"/>
+            <a:ext cx="4389120" cy="868680"/>
+          </a:xfrm>
+          <a:prstGeom prst="rect">
+            <a:avLst/>
+          </a:prstGeom>
+          <a:noFill/>
+          <a:ln/>
+        </p:spPr>
+        <p:txBody>
+          <a:bodyPr wrap="square" lIns="0" tIns="0" rIns="0" bIns="0" rtlCol="0" anchor="ctr"/>
+          <a:lstStyle/>
+          <a:p>
+            <a:pPr indent="0" marL="0">
+              <a:spcAft>
+                <a:spcPts val="400"/>
+              </a:spcAft>
+              <a:buNone/>
+            </a:pPr>
+            <a:r>
+              <a:rPr lang="en-US" sz="1300" dirty="0">
                 <a:solidFill>
                   <a:srgbClr val="E8DFD0"/>
                 </a:solidFill>
@@ -13940,9 +13986,29 @@
                 <a:ea typeface="Calibri" pitchFamily="34" charset="-122"/>
                 <a:cs typeface="Calibri" pitchFamily="34" charset="-120"/>
               </a:rPr>
-              <a:t>Stimmt eure Vermutung vom Ende des Lückentextes?</a:t>
-            </a:r>
-            <a:endParaRPr lang="en-US" sz="1400" dirty="0"/>
+              <a:t>1. Notiere beim Hören alle Probleme in Stichpunkten untereinander.</a:t>
+            </a:r>
+            <a:endParaRPr lang="en-US" sz="1300" dirty="0"/>
+          </a:p>
+          <a:p>
+            <a:pPr indent="0" marL="0">
+              <a:spcAft>
+                <a:spcPts val="400"/>
+              </a:spcAft>
+              <a:buNone/>
+            </a:pPr>
+            <a:r>
+              <a:rPr lang="en-US" sz="1300" dirty="0">
+                <a:solidFill>
+                  <a:srgbClr val="E8DFD0"/>
+                </a:solidFill>
+                <a:latin typeface="Calibri" pitchFamily="34" charset="0"/>
+                <a:ea typeface="Calibri" pitchFamily="34" charset="-122"/>
+                <a:cs typeface="Calibri" pitchFamily="34" charset="-120"/>
+              </a:rPr>
+              <a:t>2. Vergleiche danach mit deiner Vermutung vom Ende des Lückentextes.</a:t>
+            </a:r>
+            <a:endParaRPr lang="en-US" sz="1300" dirty="0"/>
           </a:p>
         </p:txBody>
       </p:sp>
@@ -14167,6 +14233,45 @@
           </a:p>
         </p:txBody>
       </p:sp>
+      <p:sp>
+        <p:nvSpPr>
+          <p:cNvPr id="4" name="Text 2"/>
+          <p:cNvSpPr txBox="1"/>
+          <p:nvPr/>
+        </p:nvSpPr>
+        <p:spPr>
+          <a:xfrm>
+            <a:off x="457200" y="1097280"/>
+            <a:ext cx="8229600" cy="320040"/>
+          </a:xfrm>
+          <a:prstGeom prst="rect">
+            <a:avLst/>
+          </a:prstGeom>
+          <a:noFill/>
+          <a:ln/>
+        </p:spPr>
+        <p:txBody>
+          <a:bodyPr wrap="square" lIns="0" tIns="0" rIns="0" bIns="0" rtlCol="0" anchor="t"/>
+          <a:lstStyle/>
+          <a:p>
+            <a:pPr indent="0" marL="0">
+              <a:buNone/>
+            </a:pPr>
+            <a:r>
+              <a:rPr lang="en-US" sz="1300" b="1" dirty="0">
+                <a:solidFill>
+                  <a:srgbClr val="5A5044"/>
+                </a:solidFill>
+                <a:latin typeface="Calibri" pitchFamily="34" charset="0"/>
+                <a:ea typeface="Calibri" pitchFamily="34" charset="-122"/>
+                <a:cs typeface="Calibri" pitchFamily="34" charset="-120"/>
+              </a:rPr>
+              <a:t>Übertrage die Tabelle in dein Heft. Lass in jeder Zeile Platz für Zeichen und Stichworte.</a:t>
+            </a:r>
+            <a:endParaRPr lang="en-US" sz="1300" dirty="0"/>
+          </a:p>
+        </p:txBody>
+      </p:sp>
       <p:graphicFrame>
         <p:nvGraphicFramePr>
           <p:cNvPr id="26" name="Table 0"/>
@@ -14182,7 +14287,7 @@
           </p:nvPr>
         </p:nvGraphicFramePr>
         <p:xfrm>
-          <a:off x="457200" y="1280160"/>
+          <a:off x="457200" y="1481328"/>
           <a:ext cx="8229600" cy="914400"/>
         </p:xfrm>
         <a:graphic>
@@ -14195,7 +14300,7 @@
                 <a:gridCol w="1645920"/>
                 <a:gridCol w="1645920"/>
               </a:tblGrid>
-              <a:tr h="475488">
+              <a:tr h="448056">
                 <a:tc>
                   <a:txBody>
                     <a:bodyPr/>
@@ -14458,7 +14563,7 @@
                   </a:tcPr>
                 </a:tc>
               </a:tr>
-              <a:tr h="475488">
+              <a:tr h="448056">
                 <a:tc>
                   <a:txBody>
                     <a:bodyPr/>
@@ -14476,7 +14581,7 @@
                           <a:ea typeface="Cambria" pitchFamily="34" charset="-122"/>
                           <a:cs typeface="Cambria" pitchFamily="34" charset="-120"/>
                         </a:rPr>
-                        <a:t>P1</a:t>
+                        <a:t>1</a:t>
                       </a:r>
                       <a:endParaRPr lang="en-US" sz="1500" dirty="0">
                         <a:latin typeface="Cambria" charset="0"/>
@@ -14710,7 +14815,7 @@
                   </a:tcPr>
                 </a:tc>
               </a:tr>
-              <a:tr h="475488">
+              <a:tr h="448056">
                 <a:tc>
                   <a:txBody>
                     <a:bodyPr/>
@@ -14728,7 +14833,7 @@
                           <a:ea typeface="Cambria" pitchFamily="34" charset="-122"/>
                           <a:cs typeface="Cambria" pitchFamily="34" charset="-120"/>
                         </a:rPr>
-                        <a:t>P2</a:t>
+                        <a:t>2</a:t>
                       </a:r>
                       <a:endParaRPr lang="en-US" sz="1500" dirty="0">
                         <a:latin typeface="Cambria" charset="0"/>
@@ -14962,7 +15067,7 @@
                   </a:tcPr>
                 </a:tc>
               </a:tr>
-              <a:tr h="475488">
+              <a:tr h="448056">
                 <a:tc>
                   <a:txBody>
                     <a:bodyPr/>
@@ -14980,7 +15085,7 @@
                           <a:ea typeface="Cambria" pitchFamily="34" charset="-122"/>
                           <a:cs typeface="Cambria" pitchFamily="34" charset="-120"/>
                         </a:rPr>
-                        <a:t>P3</a:t>
+                        <a:t>3</a:t>
                       </a:r>
                       <a:endParaRPr lang="en-US" sz="1500" dirty="0">
                         <a:latin typeface="Cambria" charset="0"/>
@@ -15214,7 +15319,7 @@
                   </a:tcPr>
                 </a:tc>
               </a:tr>
-              <a:tr h="475488">
+              <a:tr h="448056">
                 <a:tc>
                   <a:txBody>
                     <a:bodyPr/>
@@ -15232,7 +15337,7 @@
                           <a:ea typeface="Cambria" pitchFamily="34" charset="-122"/>
                           <a:cs typeface="Cambria" pitchFamily="34" charset="-120"/>
                         </a:rPr>
-                        <a:t>P4</a:t>
+                        <a:t>4</a:t>
                       </a:r>
                       <a:endParaRPr lang="en-US" sz="1500" dirty="0">
                         <a:latin typeface="Cambria" charset="0"/>
@@ -15466,7 +15571,7 @@
                   </a:tcPr>
                 </a:tc>
               </a:tr>
-              <a:tr h="475488">
+              <a:tr h="448056">
                 <a:tc>
                   <a:txBody>
                     <a:bodyPr/>
@@ -15484,7 +15589,7 @@
                           <a:ea typeface="Cambria" pitchFamily="34" charset="-122"/>
                           <a:cs typeface="Cambria" pitchFamily="34" charset="-120"/>
                         </a:rPr>
-                        <a:t>P5</a:t>
+                        <a:t>5</a:t>
                       </a:r>
                       <a:endParaRPr lang="en-US" sz="1500" dirty="0">
                         <a:latin typeface="Cambria" charset="0"/>
@@ -15724,7 +15829,7 @@
       </p:graphicFrame>
       <p:sp>
         <p:nvSpPr>
-          <p:cNvPr id="5" name="Text 2"/>
+          <p:cNvPr id="6" name="Text 3"/>
           <p:cNvSpPr txBox="1"/>
           <p:nvPr/>
         </p:nvSpPr>
@@ -15763,7 +15868,7 @@
       </p:sp>
       <p:sp>
         <p:nvSpPr>
-          <p:cNvPr id="6" name="Text 3"/>
+          <p:cNvPr id="7" name="Text 4"/>
           <p:cNvSpPr txBox="1"/>
           <p:nvPr/>
         </p:nvSpPr>
@@ -15802,7 +15907,7 @@
       </p:sp>
       <p:sp>
         <p:nvSpPr>
-          <p:cNvPr id="7" name="Text 4"/>
+          <p:cNvPr id="8" name="Text 5"/>
           <p:cNvSpPr txBox="1"/>
           <p:nvPr/>
         </p:nvSpPr>
@@ -16068,8 +16173,8 @@
         </p:nvSpPr>
         <p:spPr>
           <a:xfrm>
-            <a:off x="1325880" y="1554480"/>
-            <a:ext cx="4023360" cy="640080"/>
+            <a:off x="1325880" y="1481328"/>
+            <a:ext cx="4114800" cy="603504"/>
           </a:xfrm>
           <a:prstGeom prst="rect">
             <a:avLst/>
@@ -16085,7 +16190,7 @@
               <a:buNone/>
             </a:pPr>
             <a:r>
-              <a:rPr lang="en-US" sz="1500" dirty="0">
+              <a:rPr lang="en-US" sz="1400" dirty="0">
                 <a:solidFill>
                   <a:srgbClr val="2B2318"/>
                 </a:solidFill>
@@ -16095,7 +16200,7 @@
               </a:rPr>
               <a:t>Lest im LB S. 20 den Abschnitt „Die Gesetzgebung des Drakon“.</a:t>
             </a:r>
-            <a:endParaRPr lang="en-US" sz="1500" dirty="0"/>
+            <a:endParaRPr lang="en-US" sz="1400" dirty="0"/>
           </a:p>
         </p:txBody>
       </p:sp>
@@ -16107,7 +16212,7 @@
         </p:nvSpPr>
         <p:spPr>
           <a:xfrm>
-            <a:off x="685800" y="2377440"/>
+            <a:off x="685800" y="2286000"/>
             <a:ext cx="457200" cy="457200"/>
           </a:xfrm>
           <a:prstGeom prst="ellipse">
@@ -16148,8 +16253,8 @@
         </p:nvSpPr>
         <p:spPr>
           <a:xfrm>
-            <a:off x="1325880" y="2377440"/>
-            <a:ext cx="4023360" cy="457200"/>
+            <a:off x="1325880" y="2194560"/>
+            <a:ext cx="4114800" cy="868680"/>
           </a:xfrm>
           <a:prstGeom prst="rect">
             <a:avLst/>
@@ -16165,7 +16270,7 @@
               <a:buNone/>
             </a:pPr>
             <a:r>
-              <a:rPr lang="en-US" sz="1500" dirty="0">
+              <a:rPr lang="en-US" sz="1400" dirty="0">
                 <a:solidFill>
                   <a:srgbClr val="2B2318"/>
                 </a:solidFill>
@@ -16173,9 +16278,9 @@
                 <a:ea typeface="Calibri" pitchFamily="34" charset="-122"/>
                 <a:cs typeface="Calibri" pitchFamily="34" charset="-120"/>
               </a:rPr>
-              <a:t>Füllt die Spalte „Drakon“ aus: ✔, ~ oder ✘.</a:t>
-            </a:r>
-            <a:endParaRPr lang="en-US" sz="1500" dirty="0"/>
+              <a:t>Prüft für jedes der fünf Probleme in eurer Tabelle: Hat Drakon es gelöst? Tragt in die Spalte „Drakon“ ein: ✔ gelöst, ~ teilweise, ✘ nicht gelöst.</a:t>
+            </a:r>
+            <a:endParaRPr lang="en-US" sz="1400" dirty="0"/>
           </a:p>
         </p:txBody>
       </p:sp>
@@ -16187,7 +16292,7 @@
         </p:nvSpPr>
         <p:spPr>
           <a:xfrm>
-            <a:off x="685800" y="3108960"/>
+            <a:off x="685800" y="3310128"/>
             <a:ext cx="457200" cy="457200"/>
           </a:xfrm>
           <a:prstGeom prst="ellipse">
@@ -16228,8 +16333,8 @@
         </p:nvSpPr>
         <p:spPr>
           <a:xfrm>
-            <a:off x="1325880" y="3108960"/>
-            <a:ext cx="4023360" cy="640080"/>
+            <a:off x="1325880" y="3246120"/>
+            <a:ext cx="4114800" cy="603504"/>
           </a:xfrm>
           <a:prstGeom prst="rect">
             <a:avLst/>
@@ -16245,7 +16350,7 @@
               <a:buNone/>
             </a:pPr>
             <a:r>
-              <a:rPr lang="en-US" sz="1500" dirty="0">
+              <a:rPr lang="en-US" sz="1400" dirty="0">
                 <a:solidFill>
                   <a:srgbClr val="2B2318"/>
                 </a:solidFill>
@@ -16253,9 +16358,9 @@
                 <a:ea typeface="Calibri" pitchFamily="34" charset="-122"/>
                 <a:cs typeface="Calibri" pitchFamily="34" charset="-120"/>
               </a:rPr>
-              <a:t>Notiert zu jedem Feld ein Stichwort als Beleg aus dem Text.</a:t>
-            </a:r>
-            <a:endParaRPr lang="en-US" sz="1500" dirty="0"/>
+              <a:t>Schreibt hinter jedes Zeichen ein Stichwort aus dem Text als Beleg.</a:t>
+            </a:r>
+            <a:endParaRPr lang="en-US" sz="1400" dirty="0"/>
           </a:p>
         </p:txBody>
       </p:sp>
@@ -16333,8 +16438,8 @@
         </p:nvSpPr>
         <p:spPr>
           <a:xfrm>
-            <a:off x="6035040" y="1920240"/>
-            <a:ext cx="2468880" cy="457200"/>
+            <a:off x="6035040" y="1874520"/>
+            <a:ext cx="2468880" cy="640080"/>
           </a:xfrm>
           <a:prstGeom prst="rect">
             <a:avLst/>
@@ -16350,7 +16455,7 @@
               <a:buNone/>
             </a:pPr>
             <a:r>
-              <a:rPr lang="en-US" sz="2400" b="1" dirty="0">
+              <a:rPr lang="en-US" sz="1700" b="1" dirty="0">
                 <a:solidFill>
                   <a:srgbClr val="FFFFFF"/>
                 </a:solidFill>
@@ -16358,9 +16463,9 @@
                 <a:ea typeface="Cambria" pitchFamily="34" charset="-122"/>
                 <a:cs typeface="Cambria" pitchFamily="34" charset="-120"/>
               </a:rPr>
-              <a:t>P3  ~</a:t>
-            </a:r>
-            <a:endParaRPr lang="en-US" sz="2400" dirty="0"/>
+              <a:t>Recht nur beim Adel: ~</a:t>
+            </a:r>
+            <a:endParaRPr lang="en-US" sz="1700" dirty="0"/>
           </a:p>
         </p:txBody>
       </p:sp>
@@ -16372,8 +16477,8 @@
         </p:nvSpPr>
         <p:spPr>
           <a:xfrm>
-            <a:off x="6035040" y="2468880"/>
-            <a:ext cx="2468880" cy="1554480"/>
+            <a:off x="6035040" y="2606040"/>
+            <a:ext cx="2468880" cy="1463040"/>
           </a:xfrm>
           <a:prstGeom prst="rect">
             <a:avLst/>
@@ -16642,12 +16747,12 @@
         </p:nvSpPr>
         <p:spPr>
           <a:xfrm>
-            <a:off x="457200" y="1325880"/>
-            <a:ext cx="4023360" cy="1691640"/>
+            <a:off x="457200" y="1280160"/>
+            <a:ext cx="4023360" cy="1463040"/>
           </a:xfrm>
           <a:prstGeom prst="roundRect">
             <a:avLst>
-              <a:gd name="adj" fmla="val 4324"/>
+              <a:gd name="adj" fmla="val 5000"/>
             </a:avLst>
           </a:prstGeom>
           <a:solidFill>
@@ -16669,7 +16774,7 @@
         </p:nvSpPr>
         <p:spPr>
           <a:xfrm>
-            <a:off x="685800" y="1508760"/>
+            <a:off x="685800" y="1417320"/>
             <a:ext cx="548640" cy="548640"/>
           </a:xfrm>
           <a:prstGeom prst="ellipse">
@@ -16710,7 +16815,7 @@
         </p:nvSpPr>
         <p:spPr>
           <a:xfrm>
-            <a:off x="1417320" y="1481328"/>
+            <a:off x="1417320" y="1389888"/>
             <a:ext cx="2834640" cy="274320"/>
           </a:xfrm>
           <a:prstGeom prst="rect">
@@ -16749,7 +16854,7 @@
         </p:nvSpPr>
         <p:spPr>
           <a:xfrm>
-            <a:off x="1417320" y="1737360"/>
+            <a:off x="1417320" y="1645920"/>
             <a:ext cx="2834640" cy="365760"/>
           </a:xfrm>
           <a:prstGeom prst="rect">
@@ -16788,8 +16893,8 @@
         </p:nvSpPr>
         <p:spPr>
           <a:xfrm>
-            <a:off x="685800" y="2240280"/>
-            <a:ext cx="3611880" cy="685800"/>
+            <a:off x="685800" y="2103120"/>
+            <a:ext cx="3611880" cy="566928"/>
           </a:xfrm>
           <a:prstGeom prst="rect">
             <a:avLst/>
@@ -16805,7 +16910,7 @@
               <a:buNone/>
             </a:pPr>
             <a:r>
-              <a:rPr lang="en-US" sz="1300" dirty="0">
+              <a:rPr lang="en-US" sz="1250" dirty="0">
                 <a:solidFill>
                   <a:srgbClr val="2B2318"/>
                 </a:solidFill>
@@ -16815,7 +16920,7 @@
               </a:rPr>
               <a:t>S. 20 ab „Die Reform Solons“ bis S. 21 „… fremde Handwerker ins Land“</a:t>
             </a:r>
-            <a:endParaRPr lang="en-US" sz="1300" dirty="0"/>
+            <a:endParaRPr lang="en-US" sz="1250" dirty="0"/>
           </a:p>
         </p:txBody>
       </p:sp>
@@ -16827,12 +16932,12 @@
         </p:nvSpPr>
         <p:spPr>
           <a:xfrm>
-            <a:off x="4663440" y="1325880"/>
-            <a:ext cx="4023360" cy="1691640"/>
+            <a:off x="4663440" y="1280160"/>
+            <a:ext cx="4023360" cy="1463040"/>
           </a:xfrm>
           <a:prstGeom prst="roundRect">
             <a:avLst>
-              <a:gd name="adj" fmla="val 4324"/>
+              <a:gd name="adj" fmla="val 5000"/>
             </a:avLst>
           </a:prstGeom>
           <a:solidFill>
@@ -16854,7 +16959,7 @@
         </p:nvSpPr>
         <p:spPr>
           <a:xfrm>
-            <a:off x="4892040" y="1508760"/>
+            <a:off x="4892040" y="1417320"/>
             <a:ext cx="548640" cy="548640"/>
           </a:xfrm>
           <a:prstGeom prst="ellipse">
@@ -16895,7 +17000,7 @@
         </p:nvSpPr>
         <p:spPr>
           <a:xfrm>
-            <a:off x="5623560" y="1481328"/>
+            <a:off x="5623560" y="1389888"/>
             <a:ext cx="2834640" cy="274320"/>
           </a:xfrm>
           <a:prstGeom prst="rect">
@@ -16934,7 +17039,7 @@
         </p:nvSpPr>
         <p:spPr>
           <a:xfrm>
-            <a:off x="5623560" y="1737360"/>
+            <a:off x="5623560" y="1645920"/>
             <a:ext cx="2834640" cy="365760"/>
           </a:xfrm>
           <a:prstGeom prst="rect">
@@ -16973,8 +17078,8 @@
         </p:nvSpPr>
         <p:spPr>
           <a:xfrm>
-            <a:off x="4892040" y="2240280"/>
-            <a:ext cx="3611880" cy="685800"/>
+            <a:off x="4892040" y="2103120"/>
+            <a:ext cx="3611880" cy="566928"/>
           </a:xfrm>
           <a:prstGeom prst="rect">
             <a:avLst/>
@@ -16990,7 +17095,7 @@
               <a:buNone/>
             </a:pPr>
             <a:r>
-              <a:rPr lang="en-US" sz="1300" dirty="0">
+              <a:rPr lang="en-US" sz="1250" dirty="0">
                 <a:solidFill>
                   <a:srgbClr val="2B2318"/>
                 </a:solidFill>
@@ -17000,7 +17105,7 @@
               </a:rPr>
               <a:t>S. 21 ab „Bei der Reform des Verfassungslebens …“ bis S. 22 „… M4, M5)“</a:t>
             </a:r>
-            <a:endParaRPr lang="en-US" sz="1300" dirty="0"/>
+            <a:endParaRPr lang="en-US" sz="1250" dirty="0"/>
           </a:p>
         </p:txBody>
       </p:sp>
@@ -17012,12 +17117,12 @@
         </p:nvSpPr>
         <p:spPr>
           <a:xfrm>
-            <a:off x="457200" y="3291840"/>
-            <a:ext cx="2606040" cy="960120"/>
+            <a:off x="457200" y="2926080"/>
+            <a:ext cx="2606040" cy="1572768"/>
           </a:xfrm>
           <a:prstGeom prst="roundRect">
             <a:avLst>
-              <a:gd name="adj" fmla="val 7619"/>
+              <a:gd name="adj" fmla="val 4651"/>
             </a:avLst>
           </a:prstGeom>
           <a:solidFill>
@@ -17039,8 +17144,8 @@
         </p:nvSpPr>
         <p:spPr>
           <a:xfrm>
-            <a:off x="640080" y="3401568"/>
-            <a:ext cx="2240280" cy="274320"/>
+            <a:off x="640080" y="3017520"/>
+            <a:ext cx="2240280" cy="256032"/>
           </a:xfrm>
           <a:prstGeom prst="rect">
             <a:avLst/>
@@ -17078,8 +17183,8 @@
         </p:nvSpPr>
         <p:spPr>
           <a:xfrm>
-            <a:off x="640080" y="3703320"/>
-            <a:ext cx="2240280" cy="411480"/>
+            <a:off x="640080" y="3273552"/>
+            <a:ext cx="2240280" cy="320040"/>
           </a:xfrm>
           <a:prstGeom prst="rect">
             <a:avLst/>
@@ -17111,13 +17216,52 @@
       </p:sp>
       <p:sp>
         <p:nvSpPr>
-          <p:cNvPr id="18" name="Shape 16"/>
+          <p:cNvPr id="18" name="Text 16"/>
+          <p:cNvSpPr txBox="1"/>
+          <p:nvPr/>
+        </p:nvSpPr>
+        <p:spPr>
+          <a:xfrm>
+            <a:off x="640080" y="3611880"/>
+            <a:ext cx="2286000" cy="841248"/>
+          </a:xfrm>
+          <a:prstGeom prst="rect">
+            <a:avLst/>
+          </a:prstGeom>
+          <a:noFill/>
+          <a:ln/>
+        </p:spPr>
+        <p:txBody>
+          <a:bodyPr wrap="square" lIns="0" tIns="0" rIns="0" bIns="0" rtlCol="0" anchor="t"/>
+          <a:lstStyle/>
+          <a:p>
+            <a:pPr indent="0" marL="0">
+              <a:buNone/>
+            </a:pPr>
+            <a:r>
+              <a:rPr lang="en-US" sz="1150" dirty="0">
+                <a:solidFill>
+                  <a:srgbClr val="E8DFD0"/>
+                </a:solidFill>
+                <a:latin typeface="Calibri" pitchFamily="34" charset="0"/>
+                <a:ea typeface="Calibri" pitchFamily="34" charset="-122"/>
+                <a:cs typeface="Calibri" pitchFamily="34" charset="-120"/>
+              </a:rPr>
+              <a:t>Lies nur deinen Abschnitt. Notiere in Stichpunkten, was Solon ändert.</a:t>
+            </a:r>
+            <a:endParaRPr lang="en-US" sz="1150" dirty="0"/>
+          </a:p>
+        </p:txBody>
+      </p:sp>
+      <p:sp>
+        <p:nvSpPr>
+          <p:cNvPr id="19" name="Shape 17"/>
           <p:cNvSpPr/>
           <p:nvPr/>
         </p:nvSpPr>
         <p:spPr>
           <a:xfrm>
-            <a:off x="3081528" y="3767328"/>
+            <a:off x="3081528" y="3703320"/>
             <a:ext cx="146304" cy="0"/>
           </a:xfrm>
           <a:prstGeom prst="line">
@@ -17135,18 +17279,18 @@
       </p:sp>
       <p:sp>
         <p:nvSpPr>
-          <p:cNvPr id="19" name="Shape 17"/>
+          <p:cNvPr id="20" name="Shape 18"/>
           <p:cNvSpPr/>
           <p:nvPr/>
         </p:nvSpPr>
         <p:spPr>
           <a:xfrm>
-            <a:off x="3246120" y="3291840"/>
-            <a:ext cx="2606040" cy="960120"/>
+            <a:off x="3246120" y="2926080"/>
+            <a:ext cx="2606040" cy="1572768"/>
           </a:xfrm>
           <a:prstGeom prst="roundRect">
             <a:avLst>
-              <a:gd name="adj" fmla="val 7619"/>
+              <a:gd name="adj" fmla="val 4651"/>
             </a:avLst>
           </a:prstGeom>
           <a:solidFill>
@@ -17162,14 +17306,14 @@
       </p:sp>
       <p:sp>
         <p:nvSpPr>
-          <p:cNvPr id="20" name="Text 18"/>
-          <p:cNvSpPr txBox="1"/>
-          <p:nvPr/>
-        </p:nvSpPr>
-        <p:spPr>
-          <a:xfrm>
-            <a:off x="3429000" y="3401568"/>
-            <a:ext cx="2240280" cy="274320"/>
+          <p:cNvPr id="21" name="Text 19"/>
+          <p:cNvSpPr txBox="1"/>
+          <p:nvPr/>
+        </p:nvSpPr>
+        <p:spPr>
+          <a:xfrm>
+            <a:off x="3429000" y="3017520"/>
+            <a:ext cx="2240280" cy="256032"/>
           </a:xfrm>
           <a:prstGeom prst="rect">
             <a:avLst/>
@@ -17201,14 +17345,14 @@
       </p:sp>
       <p:sp>
         <p:nvSpPr>
-          <p:cNvPr id="21" name="Text 19"/>
-          <p:cNvSpPr txBox="1"/>
-          <p:nvPr/>
-        </p:nvSpPr>
-        <p:spPr>
-          <a:xfrm>
-            <a:off x="3429000" y="3703320"/>
-            <a:ext cx="2240280" cy="411480"/>
+          <p:cNvPr id="22" name="Text 20"/>
+          <p:cNvSpPr txBox="1"/>
+          <p:nvPr/>
+        </p:nvSpPr>
+        <p:spPr>
+          <a:xfrm>
+            <a:off x="3429000" y="3273552"/>
+            <a:ext cx="2240280" cy="320040"/>
           </a:xfrm>
           <a:prstGeom prst="rect">
             <a:avLst/>
@@ -17232,7 +17376,7 @@
                 <a:ea typeface="Calibri" pitchFamily="34" charset="-122"/>
                 <a:cs typeface="Calibri" pitchFamily="34" charset="-120"/>
               </a:rPr>
-              <a:t>Dem Partner erklären</a:t>
+              <a:t>Erklären</a:t>
             </a:r>
             <a:endParaRPr lang="en-US" sz="1600" dirty="0"/>
           </a:p>
@@ -17240,13 +17384,52 @@
       </p:sp>
       <p:sp>
         <p:nvSpPr>
-          <p:cNvPr id="22" name="Shape 20"/>
+          <p:cNvPr id="23" name="Text 21"/>
+          <p:cNvSpPr txBox="1"/>
+          <p:nvPr/>
+        </p:nvSpPr>
+        <p:spPr>
+          <a:xfrm>
+            <a:off x="3429000" y="3611880"/>
+            <a:ext cx="2286000" cy="841248"/>
+          </a:xfrm>
+          <a:prstGeom prst="rect">
+            <a:avLst/>
+          </a:prstGeom>
+          <a:noFill/>
+          <a:ln/>
+        </p:spPr>
+        <p:txBody>
+          <a:bodyPr wrap="square" lIns="0" tIns="0" rIns="0" bIns="0" rtlCol="0" anchor="t"/>
+          <a:lstStyle/>
+          <a:p>
+            <a:pPr indent="0" marL="0">
+              <a:buNone/>
+            </a:pPr>
+            <a:r>
+              <a:rPr lang="en-US" sz="1150" dirty="0">
+                <a:solidFill>
+                  <a:srgbClr val="E8DFD0"/>
+                </a:solidFill>
+                <a:latin typeface="Calibri" pitchFamily="34" charset="0"/>
+                <a:ea typeface="Calibri" pitchFamily="34" charset="-122"/>
+                <a:cs typeface="Calibri" pitchFamily="34" charset="-120"/>
+              </a:rPr>
+              <a:t>Erkläre deinem Partner mit deinen Notizen, was Solon ändert. Der Partner hört zu und fragt nach.</a:t>
+            </a:r>
+            <a:endParaRPr lang="en-US" sz="1150" dirty="0"/>
+          </a:p>
+        </p:txBody>
+      </p:sp>
+      <p:sp>
+        <p:nvSpPr>
+          <p:cNvPr id="24" name="Shape 22"/>
           <p:cNvSpPr/>
           <p:nvPr/>
         </p:nvSpPr>
         <p:spPr>
           <a:xfrm>
-            <a:off x="5870448" y="3767328"/>
+            <a:off x="5870448" y="3703320"/>
             <a:ext cx="146304" cy="0"/>
           </a:xfrm>
           <a:prstGeom prst="line">
@@ -17264,18 +17447,18 @@
       </p:sp>
       <p:sp>
         <p:nvSpPr>
-          <p:cNvPr id="23" name="Shape 21"/>
+          <p:cNvPr id="25" name="Shape 23"/>
           <p:cNvSpPr/>
           <p:nvPr/>
         </p:nvSpPr>
         <p:spPr>
           <a:xfrm>
-            <a:off x="6035040" y="3291840"/>
-            <a:ext cx="2606040" cy="960120"/>
+            <a:off x="6035040" y="2926080"/>
+            <a:ext cx="2606040" cy="1572768"/>
           </a:xfrm>
           <a:prstGeom prst="roundRect">
             <a:avLst>
-              <a:gd name="adj" fmla="val 7619"/>
+              <a:gd name="adj" fmla="val 4651"/>
             </a:avLst>
           </a:prstGeom>
           <a:solidFill>
@@ -17291,14 +17474,14 @@
       </p:sp>
       <p:sp>
         <p:nvSpPr>
-          <p:cNvPr id="24" name="Text 22"/>
-          <p:cNvSpPr txBox="1"/>
-          <p:nvPr/>
-        </p:nvSpPr>
-        <p:spPr>
-          <a:xfrm>
-            <a:off x="6217920" y="3401568"/>
-            <a:ext cx="2240280" cy="274320"/>
+          <p:cNvPr id="26" name="Text 24"/>
+          <p:cNvSpPr txBox="1"/>
+          <p:nvPr/>
+        </p:nvSpPr>
+        <p:spPr>
+          <a:xfrm>
+            <a:off x="6217920" y="3017520"/>
+            <a:ext cx="2240280" cy="256032"/>
           </a:xfrm>
           <a:prstGeom prst="rect">
             <a:avLst/>
@@ -17330,14 +17513,14 @@
       </p:sp>
       <p:sp>
         <p:nvSpPr>
-          <p:cNvPr id="25" name="Text 23"/>
-          <p:cNvSpPr txBox="1"/>
-          <p:nvPr/>
-        </p:nvSpPr>
-        <p:spPr>
-          <a:xfrm>
-            <a:off x="6217920" y="3703320"/>
-            <a:ext cx="2240280" cy="411480"/>
+          <p:cNvPr id="27" name="Text 25"/>
+          <p:cNvSpPr txBox="1"/>
+          <p:nvPr/>
+        </p:nvSpPr>
+        <p:spPr>
+          <a:xfrm>
+            <a:off x="6217920" y="3273552"/>
+            <a:ext cx="2240280" cy="320040"/>
           </a:xfrm>
           <a:prstGeom prst="rect">
             <a:avLst/>
@@ -17361,7 +17544,7 @@
                 <a:ea typeface="Calibri" pitchFamily="34" charset="-122"/>
                 <a:cs typeface="Calibri" pitchFamily="34" charset="-120"/>
               </a:rPr>
-              <a:t>Spalte „Solon“ ausfüllen</a:t>
+              <a:t>Eintragen</a:t>
             </a:r>
             <a:endParaRPr lang="en-US" sz="1600" dirty="0"/>
           </a:p>
@@ -17369,7 +17552,46 @@
       </p:sp>
       <p:sp>
         <p:nvSpPr>
-          <p:cNvPr id="26" name="Text 24"/>
+          <p:cNvPr id="28" name="Text 26"/>
+          <p:cNvSpPr txBox="1"/>
+          <p:nvPr/>
+        </p:nvSpPr>
+        <p:spPr>
+          <a:xfrm>
+            <a:off x="6217920" y="3611880"/>
+            <a:ext cx="2286000" cy="841248"/>
+          </a:xfrm>
+          <a:prstGeom prst="rect">
+            <a:avLst/>
+          </a:prstGeom>
+          <a:noFill/>
+          <a:ln/>
+        </p:spPr>
+        <p:txBody>
+          <a:bodyPr wrap="square" lIns="0" tIns="0" rIns="0" bIns="0" rtlCol="0" anchor="t"/>
+          <a:lstStyle/>
+          <a:p>
+            <a:pPr indent="0" marL="0">
+              <a:buNone/>
+            </a:pPr>
+            <a:r>
+              <a:rPr lang="en-US" sz="1150" dirty="0">
+                <a:solidFill>
+                  <a:srgbClr val="E8DFD0"/>
+                </a:solidFill>
+                <a:latin typeface="Calibri" pitchFamily="34" charset="0"/>
+                <a:ea typeface="Calibri" pitchFamily="34" charset="-122"/>
+                <a:cs typeface="Calibri" pitchFamily="34" charset="-120"/>
+              </a:rPr>
+              <a:t>Tragt gemeinsam die Spalte „Solon“ ein: Zeichen und Beleg für jedes Problem.</a:t>
+            </a:r>
+            <a:endParaRPr lang="en-US" sz="1150" dirty="0"/>
+          </a:p>
+        </p:txBody>
+      </p:sp>
+      <p:sp>
+        <p:nvSpPr>
+          <p:cNvPr id="29" name="Text 27"/>
           <p:cNvSpPr txBox="1"/>
           <p:nvPr/>
         </p:nvSpPr>
@@ -17408,7 +17630,7 @@
       </p:sp>
       <p:sp>
         <p:nvSpPr>
-          <p:cNvPr id="27" name="Text 25"/>
+          <p:cNvPr id="30" name="Text 28"/>
           <p:cNvSpPr txBox="1"/>
           <p:nvPr/>
         </p:nvSpPr>
@@ -17705,8 +17927,8 @@
         </p:nvSpPr>
         <p:spPr>
           <a:xfrm>
-            <a:off x="6309360" y="1874520"/>
-            <a:ext cx="2194560" cy="1280160"/>
+            <a:off x="6309360" y="1828800"/>
+            <a:ext cx="2194560" cy="960120"/>
           </a:xfrm>
           <a:prstGeom prst="rect">
             <a:avLst/>
@@ -17722,7 +17944,7 @@
               <a:buNone/>
             </a:pPr>
             <a:r>
-              <a:rPr lang="en-US" sz="1700" b="1" dirty="0">
+              <a:rPr lang="en-US" sz="1600" b="1" dirty="0">
                 <a:solidFill>
                   <a:srgbClr val="FFFFFF"/>
                 </a:solidFill>
@@ -17730,9 +17952,9 @@
                 <a:ea typeface="Cambria" pitchFamily="34" charset="-122"/>
                 <a:cs typeface="Cambria" pitchFamily="34" charset="-120"/>
               </a:rPr>
-              <a:t>Prüft eure Einschätzung zu P4: Politische Macht nur beim Adel.</a:t>
-            </a:r>
-            <a:endParaRPr lang="en-US" sz="1700" dirty="0"/>
+              <a:t>Achtet auf die Zeile „Politische Macht nur beim Adel“.</a:t>
+            </a:r>
+            <a:endParaRPr lang="en-US" sz="1600" dirty="0"/>
           </a:p>
         </p:txBody>
       </p:sp>
@@ -17744,8 +17966,8 @@
         </p:nvSpPr>
         <p:spPr>
           <a:xfrm>
-            <a:off x="6309360" y="3383280"/>
-            <a:ext cx="2194560" cy="548640"/>
+            <a:off x="6309360" y="2834640"/>
+            <a:ext cx="2194560" cy="1371600"/>
           </a:xfrm>
           <a:prstGeom prst="rect">
             <a:avLst/>
@@ -17761,7 +17983,7 @@
               <a:buNone/>
             </a:pPr>
             <a:r>
-              <a:rPr lang="en-US" sz="1400" dirty="0">
+              <a:rPr lang="en-US" sz="1250" dirty="0">
                 <a:solidFill>
                   <a:srgbClr val="E8DFD0"/>
                 </a:solidFill>
@@ -17769,9 +17991,9 @@
                 <a:ea typeface="Calibri" pitchFamily="34" charset="-122"/>
                 <a:cs typeface="Calibri" pitchFamily="34" charset="-120"/>
               </a:rPr>
-              <a:t>Bleibt ihr bei eurem Zeichen?</a:t>
-            </a:r>
-            <a:endParaRPr lang="en-US" sz="1400" dirty="0"/>
+              <a:t>Stimmt euer Zeichen in der Spalte „Solon“? Korrigiert es, falls nötig, und ergänzt einen Beleg aus dem Video.</a:t>
+            </a:r>
+            <a:endParaRPr lang="en-US" sz="1250" dirty="0"/>
           </a:p>
         </p:txBody>
       </p:sp>
@@ -18272,7 +18494,7 @@
                           <a:ea typeface="Cambria" pitchFamily="34" charset="-122"/>
                           <a:cs typeface="Cambria" pitchFamily="34" charset="-120"/>
                         </a:rPr>
-                        <a:t>P1</a:t>
+                        <a:t>1</a:t>
                       </a:r>
                       <a:endParaRPr lang="en-US" sz="1500" dirty="0">
                         <a:latin typeface="Cambria" charset="0"/>
@@ -18546,7 +18768,7 @@
                           <a:ea typeface="Cambria" pitchFamily="34" charset="-122"/>
                           <a:cs typeface="Cambria" pitchFamily="34" charset="-120"/>
                         </a:rPr>
-                        <a:t>P2</a:t>
+                        <a:t>2</a:t>
                       </a:r>
                       <a:endParaRPr lang="en-US" sz="1500" dirty="0">
                         <a:latin typeface="Cambria" charset="0"/>
@@ -18820,7 +19042,7 @@
                           <a:ea typeface="Cambria" pitchFamily="34" charset="-122"/>
                           <a:cs typeface="Cambria" pitchFamily="34" charset="-120"/>
                         </a:rPr>
-                        <a:t>P3</a:t>
+                        <a:t>3</a:t>
                       </a:r>
                       <a:endParaRPr lang="en-US" sz="1500" dirty="0">
                         <a:latin typeface="Cambria" charset="0"/>
@@ -19094,7 +19316,7 @@
                           <a:ea typeface="Cambria" pitchFamily="34" charset="-122"/>
                           <a:cs typeface="Cambria" pitchFamily="34" charset="-120"/>
                         </a:rPr>
-                        <a:t>P4</a:t>
+                        <a:t>4</a:t>
                       </a:r>
                       <a:endParaRPr lang="en-US" sz="1500" dirty="0">
                         <a:latin typeface="Cambria" charset="0"/>
@@ -19368,7 +19590,7 @@
                           <a:ea typeface="Cambria" pitchFamily="34" charset="-122"/>
                           <a:cs typeface="Cambria" pitchFamily="34" charset="-120"/>
                         </a:rPr>
-                        <a:t>P5</a:t>
+                        <a:t>5</a:t>
                       </a:r>
                       <a:endParaRPr lang="en-US" sz="1500" dirty="0">
                         <a:latin typeface="Cambria" charset="0"/>
@@ -20522,7 +20744,7 @@
                 <a:ea typeface="Calibri" pitchFamily="34" charset="-122"/>
                 <a:cs typeface="Calibri" pitchFamily="34" charset="-120"/>
               </a:rPr>
-              <a:t>3–4 Sätze, gestützt auf eure Tabelle</a:t>
+              <a:t>3–4 Sätze · nutze deine Tabelle</a:t>
             </a:r>
             <a:endParaRPr lang="en-US" sz="1100" dirty="0"/>
           </a:p>
@@ -20670,7 +20892,7 @@
                 <a:ea typeface="Calibri" pitchFamily="34" charset="-122"/>
                 <a:cs typeface="Calibri" pitchFamily="34" charset="-120"/>
               </a:rPr>
-              <a:t>2–3 Sätze</a:t>
+              <a:t>2–3 Sätze · nenne deinen Maßstab</a:t>
             </a:r>
             <a:endParaRPr lang="en-US" sz="1100" dirty="0"/>
           </a:p>

</xml_diff>